<commit_message>
METS Data Flow Diagram update and Data Validation Procedures added
METS Data Flow Diagram update and Data Validation Procedures added
</commit_message>
<xml_diff>
--- a/design.pptx
+++ b/design.pptx
@@ -104,6 +104,11 @@
       </a:defRPr>
     </a:lvl9pPr>
   </p:defaultTextStyle>
+  <p:extLst>
+    <p:ext uri="{EFAFB233-063F-42B5-8137-9DF3F51BA10A}">
+      <p15:sldGuideLst xmlns:p15="http://schemas.microsoft.com/office/powerpoint/2012/main"/>
+    </p:ext>
+  </p:extLst>
 </p:presentation>
 </file>
 
@@ -256,7 +261,7 @@
           <a:p>
             <a:fld id="{D2D0B739-CD64-4658-B147-CD72457FF58D}" type="datetimeFigureOut">
               <a:rPr lang="en-US" smtClean="0"/>
-              <a:t>12/9/2025</a:t>
+              <a:t>2/21/2026</a:t>
             </a:fld>
             <a:endParaRPr lang="en-US"/>
           </a:p>
@@ -310,7 +315,7 @@
           <a:p>
             <a:fld id="{C239BF8D-DAFF-436F-9EED-5555EA84F8B5}" type="slidenum">
               <a:rPr lang="en-US" smtClean="0"/>
-              <a:t>‹N°›</a:t>
+              <a:t>‹#›</a:t>
             </a:fld>
             <a:endParaRPr lang="en-US"/>
           </a:p>
@@ -456,7 +461,7 @@
           <a:p>
             <a:fld id="{D2D0B739-CD64-4658-B147-CD72457FF58D}" type="datetimeFigureOut">
               <a:rPr lang="en-US" smtClean="0"/>
-              <a:t>12/9/2025</a:t>
+              <a:t>2/21/2026</a:t>
             </a:fld>
             <a:endParaRPr lang="en-US"/>
           </a:p>
@@ -510,7 +515,7 @@
           <a:p>
             <a:fld id="{C239BF8D-DAFF-436F-9EED-5555EA84F8B5}" type="slidenum">
               <a:rPr lang="en-US" smtClean="0"/>
-              <a:t>‹N°›</a:t>
+              <a:t>‹#›</a:t>
             </a:fld>
             <a:endParaRPr lang="en-US"/>
           </a:p>
@@ -666,7 +671,7 @@
           <a:p>
             <a:fld id="{D2D0B739-CD64-4658-B147-CD72457FF58D}" type="datetimeFigureOut">
               <a:rPr lang="en-US" smtClean="0"/>
-              <a:t>12/9/2025</a:t>
+              <a:t>2/21/2026</a:t>
             </a:fld>
             <a:endParaRPr lang="en-US"/>
           </a:p>
@@ -720,7 +725,7 @@
           <a:p>
             <a:fld id="{C239BF8D-DAFF-436F-9EED-5555EA84F8B5}" type="slidenum">
               <a:rPr lang="en-US" smtClean="0"/>
-              <a:t>‹N°›</a:t>
+              <a:t>‹#›</a:t>
             </a:fld>
             <a:endParaRPr lang="en-US"/>
           </a:p>
@@ -866,7 +871,7 @@
           <a:p>
             <a:fld id="{D2D0B739-CD64-4658-B147-CD72457FF58D}" type="datetimeFigureOut">
               <a:rPr lang="en-US" smtClean="0"/>
-              <a:t>12/9/2025</a:t>
+              <a:t>2/21/2026</a:t>
             </a:fld>
             <a:endParaRPr lang="en-US"/>
           </a:p>
@@ -920,7 +925,7 @@
           <a:p>
             <a:fld id="{C239BF8D-DAFF-436F-9EED-5555EA84F8B5}" type="slidenum">
               <a:rPr lang="en-US" smtClean="0"/>
-              <a:t>‹N°›</a:t>
+              <a:t>‹#›</a:t>
             </a:fld>
             <a:endParaRPr lang="en-US"/>
           </a:p>
@@ -1142,7 +1147,7 @@
           <a:p>
             <a:fld id="{D2D0B739-CD64-4658-B147-CD72457FF58D}" type="datetimeFigureOut">
               <a:rPr lang="en-US" smtClean="0"/>
-              <a:t>12/9/2025</a:t>
+              <a:t>2/21/2026</a:t>
             </a:fld>
             <a:endParaRPr lang="en-US"/>
           </a:p>
@@ -1196,7 +1201,7 @@
           <a:p>
             <a:fld id="{C239BF8D-DAFF-436F-9EED-5555EA84F8B5}" type="slidenum">
               <a:rPr lang="en-US" smtClean="0"/>
-              <a:t>‹N°›</a:t>
+              <a:t>‹#›</a:t>
             </a:fld>
             <a:endParaRPr lang="en-US"/>
           </a:p>
@@ -1410,7 +1415,7 @@
           <a:p>
             <a:fld id="{D2D0B739-CD64-4658-B147-CD72457FF58D}" type="datetimeFigureOut">
               <a:rPr lang="en-US" smtClean="0"/>
-              <a:t>12/9/2025</a:t>
+              <a:t>2/21/2026</a:t>
             </a:fld>
             <a:endParaRPr lang="en-US"/>
           </a:p>
@@ -1464,7 +1469,7 @@
           <a:p>
             <a:fld id="{C239BF8D-DAFF-436F-9EED-5555EA84F8B5}" type="slidenum">
               <a:rPr lang="en-US" smtClean="0"/>
-              <a:t>‹N°›</a:t>
+              <a:t>‹#›</a:t>
             </a:fld>
             <a:endParaRPr lang="en-US"/>
           </a:p>
@@ -1825,7 +1830,7 @@
           <a:p>
             <a:fld id="{D2D0B739-CD64-4658-B147-CD72457FF58D}" type="datetimeFigureOut">
               <a:rPr lang="en-US" smtClean="0"/>
-              <a:t>12/9/2025</a:t>
+              <a:t>2/21/2026</a:t>
             </a:fld>
             <a:endParaRPr lang="en-US"/>
           </a:p>
@@ -1879,7 +1884,7 @@
           <a:p>
             <a:fld id="{C239BF8D-DAFF-436F-9EED-5555EA84F8B5}" type="slidenum">
               <a:rPr lang="en-US" smtClean="0"/>
-              <a:t>‹N°›</a:t>
+              <a:t>‹#›</a:t>
             </a:fld>
             <a:endParaRPr lang="en-US"/>
           </a:p>
@@ -1967,7 +1972,7 @@
           <a:p>
             <a:fld id="{D2D0B739-CD64-4658-B147-CD72457FF58D}" type="datetimeFigureOut">
               <a:rPr lang="en-US" smtClean="0"/>
-              <a:t>12/9/2025</a:t>
+              <a:t>2/21/2026</a:t>
             </a:fld>
             <a:endParaRPr lang="en-US"/>
           </a:p>
@@ -2021,7 +2026,7 @@
           <a:p>
             <a:fld id="{C239BF8D-DAFF-436F-9EED-5555EA84F8B5}" type="slidenum">
               <a:rPr lang="en-US" smtClean="0"/>
-              <a:t>‹N°›</a:t>
+              <a:t>‹#›</a:t>
             </a:fld>
             <a:endParaRPr lang="en-US"/>
           </a:p>
@@ -2080,7 +2085,7 @@
           <a:p>
             <a:fld id="{D2D0B739-CD64-4658-B147-CD72457FF58D}" type="datetimeFigureOut">
               <a:rPr lang="en-US" smtClean="0"/>
-              <a:t>12/9/2025</a:t>
+              <a:t>2/21/2026</a:t>
             </a:fld>
             <a:endParaRPr lang="en-US"/>
           </a:p>
@@ -2134,7 +2139,7 @@
           <a:p>
             <a:fld id="{C239BF8D-DAFF-436F-9EED-5555EA84F8B5}" type="slidenum">
               <a:rPr lang="en-US" smtClean="0"/>
-              <a:t>‹N°›</a:t>
+              <a:t>‹#›</a:t>
             </a:fld>
             <a:endParaRPr lang="en-US"/>
           </a:p>
@@ -2393,7 +2398,7 @@
           <a:p>
             <a:fld id="{D2D0B739-CD64-4658-B147-CD72457FF58D}" type="datetimeFigureOut">
               <a:rPr lang="en-US" smtClean="0"/>
-              <a:t>12/9/2025</a:t>
+              <a:t>2/21/2026</a:t>
             </a:fld>
             <a:endParaRPr lang="en-US"/>
           </a:p>
@@ -2447,7 +2452,7 @@
           <a:p>
             <a:fld id="{C239BF8D-DAFF-436F-9EED-5555EA84F8B5}" type="slidenum">
               <a:rPr lang="en-US" smtClean="0"/>
-              <a:t>‹N°›</a:t>
+              <a:t>‹#›</a:t>
             </a:fld>
             <a:endParaRPr lang="en-US"/>
           </a:p>
@@ -2682,7 +2687,7 @@
           <a:p>
             <a:fld id="{D2D0B739-CD64-4658-B147-CD72457FF58D}" type="datetimeFigureOut">
               <a:rPr lang="en-US" smtClean="0"/>
-              <a:t>12/9/2025</a:t>
+              <a:t>2/21/2026</a:t>
             </a:fld>
             <a:endParaRPr lang="en-US"/>
           </a:p>
@@ -2736,7 +2741,7 @@
           <a:p>
             <a:fld id="{C239BF8D-DAFF-436F-9EED-5555EA84F8B5}" type="slidenum">
               <a:rPr lang="en-US" smtClean="0"/>
-              <a:t>‹N°›</a:t>
+              <a:t>‹#›</a:t>
             </a:fld>
             <a:endParaRPr lang="en-US"/>
           </a:p>
@@ -2925,7 +2930,7 @@
           <a:p>
             <a:fld id="{D2D0B739-CD64-4658-B147-CD72457FF58D}" type="datetimeFigureOut">
               <a:rPr lang="en-US" smtClean="0"/>
-              <a:t>12/9/2025</a:t>
+              <a:t>2/21/2026</a:t>
             </a:fld>
             <a:endParaRPr lang="en-US"/>
           </a:p>
@@ -3015,9 +3020,57 @@
           <a:p>
             <a:fld id="{C239BF8D-DAFF-436F-9EED-5555EA84F8B5}" type="slidenum">
               <a:rPr lang="en-US" smtClean="0"/>
-              <a:t>‹N°›</a:t>
+              <a:t>‹#›</a:t>
             </a:fld>
             <a:endParaRPr lang="en-US"/>
+          </a:p>
+        </p:txBody>
+      </p:sp>
+      <p:sp>
+        <p:nvSpPr>
+          <p:cNvPr id="8" name="TextBox 7">
+            <a:extLst>
+              <a:ext uri="{FF2B5EF4-FFF2-40B4-BE49-F238E27FC236}">
+                <a16:creationId xmlns:a16="http://schemas.microsoft.com/office/drawing/2014/main" id="{9E75E8FC-5EAF-2924-86BA-A7D37AAF2133}"/>
+              </a:ext>
+            </a:extLst>
+          </p:cNvPr>
+          <p:cNvSpPr txBox="1"/>
+          <p:nvPr userDrawn="1">
+            <p:extLst>
+              <p:ext uri="{1162E1C5-73C7-4A58-AE30-91384D911F3F}">
+                <p184:classification xmlns:p184="http://schemas.microsoft.com/office/powerpoint/2018/4/main" val="ftr"/>
+              </p:ext>
+            </p:extLst>
+          </p:nvPr>
+        </p:nvSpPr>
+        <p:spPr>
+          <a:xfrm>
+            <a:off x="11210925" y="6642100"/>
+            <a:ext cx="942975" cy="152400"/>
+          </a:xfrm>
+          <a:prstGeom prst="rect">
+            <a:avLst/>
+          </a:prstGeom>
+        </p:spPr>
+        <p:txBody>
+          <a:bodyPr horzOverflow="overflow" lIns="0" tIns="0" rIns="0" bIns="0">
+            <a:spAutoFit/>
+          </a:bodyPr>
+          <a:lstStyle/>
+          <a:p>
+            <a:pPr algn="l"/>
+            <a:r>
+              <a:rPr lang="en-US" sz="1000">
+                <a:solidFill>
+                  <a:srgbClr val="000000">
+                    <a:alpha val="50000"/>
+                  </a:srgbClr>
+                </a:solidFill>
+                <a:latin typeface="Aptos" panose="020B0004020202020204" pitchFamily="34" charset="0"/>
+              </a:rPr>
+              <a:t>Official Use Only</a:t>
+            </a:r>
           </a:p>
         </p:txBody>
       </p:sp>
@@ -6937,7 +6990,7 @@
             <a:avLst/>
           </a:prstGeom>
           <a:solidFill>
-            <a:schemeClr val="bg1"/>
+            <a:schemeClr val="accent2"/>
           </a:solidFill>
           <a:ln w="6350"/>
         </p:spPr>
@@ -6964,14 +7017,14 @@
             <a:r>
               <a:rPr lang="fr-FR" sz="1000" dirty="0">
                 <a:solidFill>
-                  <a:schemeClr val="tx1"/>
+                  <a:srgbClr val="FFFF00"/>
                 </a:solidFill>
               </a:rPr>
-              <a:t>Transfert DHIS2</a:t>
+              <a:t>Transfert to DHIS2</a:t>
             </a:r>
             <a:endParaRPr lang="fr-FR" sz="1000" noProof="0" dirty="0">
               <a:solidFill>
-                <a:schemeClr val="tx1"/>
+                <a:srgbClr val="FFFF00"/>
               </a:solidFill>
             </a:endParaRPr>
           </a:p>
@@ -7077,7 +7130,7 @@
             <a:r>
               <a:rPr lang="fr-FR" sz="1200" b="1" noProof="0" dirty="0">
                 <a:solidFill>
-                  <a:schemeClr val="tx1"/>
+                  <a:srgbClr val="FF0000"/>
                 </a:solidFill>
               </a:rPr>
               <a:t>DHIS2</a:t>

</xml_diff>